<commit_message>
Repaso Parciales gestión de servicios de la información
</commit_message>
<xml_diff>
--- a/Licenciatura en CiberDefensa/Gestion de servicios de informacion/Clase 1 y 2/Clase 1/Clase 2 Fundamentos y principios de las metodologías de gestión (Parte 1) .pptx
+++ b/Licenciatura en CiberDefensa/Gestion de servicios de informacion/Clase 1 y 2/Clase 1/Clase 2 Fundamentos y principios de las metodologías de gestión (Parte 1) .pptx
@@ -278,6 +278,65 @@
     </p:ext>
   </p:extLst>
 </p:presentation>
+</file>
+
+<file path=ppt/changesInfos/changesInfo1.xml><?xml version="1.0" encoding="utf-8"?>
+<pc:chgInfo xmlns:a="http://schemas.openxmlformats.org/drawingml/2006/main" xmlns:r="http://schemas.openxmlformats.org/officeDocument/2006/relationships" xmlns:ac="http://schemas.microsoft.com/office/drawing/2013/main/command" xmlns:pc="http://schemas.microsoft.com/office/powerpoint/2013/main/command">
+  <pc:docChgLst>
+    <pc:chgData name="Martin Torres" userId="8eb5c97ff98cd4ad" providerId="LiveId" clId="{CF18D003-9F5F-4F96-9EC4-0D2F9B903059}"/>
+    <pc:docChg chg="modSld">
+      <pc:chgData name="Martin Torres" userId="8eb5c97ff98cd4ad" providerId="LiveId" clId="{CF18D003-9F5F-4F96-9EC4-0D2F9B903059}" dt="2025-05-11T14:09:37.699" v="2" actId="14100"/>
+      <pc:docMkLst>
+        <pc:docMk/>
+      </pc:docMkLst>
+      <pc:sldChg chg="modSp mod">
+        <pc:chgData name="Martin Torres" userId="8eb5c97ff98cd4ad" providerId="LiveId" clId="{CF18D003-9F5F-4F96-9EC4-0D2F9B903059}" dt="2025-05-11T13:58:35.762" v="0" actId="1076"/>
+        <pc:sldMkLst>
+          <pc:docMk/>
+          <pc:sldMk cId="0" sldId="265"/>
+        </pc:sldMkLst>
+        <pc:spChg chg="mod">
+          <ac:chgData name="Martin Torres" userId="8eb5c97ff98cd4ad" providerId="LiveId" clId="{CF18D003-9F5F-4F96-9EC4-0D2F9B903059}" dt="2025-05-11T13:58:35.762" v="0" actId="1076"/>
+          <ac:spMkLst>
+            <pc:docMk/>
+            <pc:sldMk cId="0" sldId="265"/>
+            <ac:spMk id="138" creationId="{00000000-0000-0000-0000-000000000000}"/>
+          </ac:spMkLst>
+        </pc:spChg>
+      </pc:sldChg>
+      <pc:sldChg chg="modSp mod">
+        <pc:chgData name="Martin Torres" userId="8eb5c97ff98cd4ad" providerId="LiveId" clId="{CF18D003-9F5F-4F96-9EC4-0D2F9B903059}" dt="2025-05-11T14:04:09.983" v="1" actId="14100"/>
+        <pc:sldMkLst>
+          <pc:docMk/>
+          <pc:sldMk cId="0" sldId="269"/>
+        </pc:sldMkLst>
+        <pc:spChg chg="mod">
+          <ac:chgData name="Martin Torres" userId="8eb5c97ff98cd4ad" providerId="LiveId" clId="{CF18D003-9F5F-4F96-9EC4-0D2F9B903059}" dt="2025-05-11T14:04:09.983" v="1" actId="14100"/>
+          <ac:spMkLst>
+            <pc:docMk/>
+            <pc:sldMk cId="0" sldId="269"/>
+            <ac:spMk id="174" creationId="{00000000-0000-0000-0000-000000000000}"/>
+          </ac:spMkLst>
+        </pc:spChg>
+      </pc:sldChg>
+      <pc:sldChg chg="modSp mod">
+        <pc:chgData name="Martin Torres" userId="8eb5c97ff98cd4ad" providerId="LiveId" clId="{CF18D003-9F5F-4F96-9EC4-0D2F9B903059}" dt="2025-05-11T14:09:37.699" v="2" actId="14100"/>
+        <pc:sldMkLst>
+          <pc:docMk/>
+          <pc:sldMk cId="0" sldId="271"/>
+        </pc:sldMkLst>
+        <pc:spChg chg="mod">
+          <ac:chgData name="Martin Torres" userId="8eb5c97ff98cd4ad" providerId="LiveId" clId="{CF18D003-9F5F-4F96-9EC4-0D2F9B903059}" dt="2025-05-11T14:09:37.699" v="2" actId="14100"/>
+          <ac:spMkLst>
+            <pc:docMk/>
+            <pc:sldMk cId="0" sldId="271"/>
+            <ac:spMk id="192" creationId="{00000000-0000-0000-0000-000000000000}"/>
+          </ac:spMkLst>
+        </pc:spChg>
+      </pc:sldChg>
+    </pc:docChg>
+  </pc:docChgLst>
+</pc:chgInfo>
 </file>
 
 <file path=ppt/notesMasters/notesMaster1.xml><?xml version="1.0" encoding="utf-8"?>
@@ -11526,7 +11585,7 @@
         </p:nvSpPr>
         <p:spPr>
           <a:xfrm>
-            <a:off x="622950" y="810200"/>
+            <a:off x="732678" y="817092"/>
             <a:ext cx="6684000" cy="463500"/>
           </a:xfrm>
           <a:prstGeom prst="rect">
@@ -11561,14 +11620,14 @@
               <a:buNone/>
             </a:pPr>
             <a:r>
-              <a:rPr lang="es" b="1">
+              <a:rPr lang="es" b="1" dirty="0">
                 <a:solidFill>
                   <a:schemeClr val="dk2"/>
                 </a:solidFill>
               </a:rPr>
               <a:t>Evolución de GSI -  Costo a socio estratégico - TI a GSI</a:t>
             </a:r>
-            <a:endParaRPr sz="1400" b="1" i="0" u="none" strike="noStrike" cap="none">
+            <a:endParaRPr sz="1400" b="1" i="0" u="none" strike="noStrike" cap="none" dirty="0">
               <a:solidFill>
                 <a:schemeClr val="dk2"/>
               </a:solidFill>
@@ -11622,14 +11681,14 @@
               <a:buChar char="❖"/>
             </a:pPr>
             <a:r>
-              <a:rPr lang="es" sz="1200">
+              <a:rPr lang="es" sz="1200" dirty="0">
                 <a:solidFill>
                   <a:schemeClr val="dk2"/>
                 </a:solidFill>
               </a:rPr>
               <a:t>En los inicios, TI era un área de soporte técnico (hardware, redes, servidores, dc, cableado).</a:t>
             </a:r>
-            <a:endParaRPr sz="1200">
+            <a:endParaRPr sz="1200" dirty="0">
               <a:solidFill>
                 <a:schemeClr val="dk2"/>
               </a:solidFill>
@@ -11653,14 +11712,14 @@
               <a:buChar char="❖"/>
             </a:pPr>
             <a:r>
-              <a:rPr lang="es" sz="1200">
+              <a:rPr lang="es" sz="1200" dirty="0">
                 <a:solidFill>
                   <a:schemeClr val="dk2"/>
                 </a:solidFill>
               </a:rPr>
               <a:t>Las decisiones eran técnicas, no orientadas al negocio.</a:t>
             </a:r>
-            <a:endParaRPr sz="1200">
+            <a:endParaRPr sz="1200" dirty="0">
               <a:solidFill>
                 <a:schemeClr val="dk2"/>
               </a:solidFill>
@@ -11684,14 +11743,14 @@
               <a:buChar char="❖"/>
             </a:pPr>
             <a:r>
-              <a:rPr lang="es" sz="1200">
+              <a:rPr lang="es" sz="1200" dirty="0">
                 <a:solidFill>
                   <a:schemeClr val="dk2"/>
                 </a:solidFill>
               </a:rPr>
               <a:t>TI se veía como un centro de costos, no como generador de valor.</a:t>
             </a:r>
-            <a:endParaRPr sz="1200">
+            <a:endParaRPr sz="1200" dirty="0">
               <a:solidFill>
                 <a:schemeClr val="dk2"/>
               </a:solidFill>
@@ -11715,14 +11774,14 @@
               <a:buChar char="❖"/>
             </a:pPr>
             <a:r>
-              <a:rPr lang="es" sz="1200">
+              <a:rPr lang="es" sz="1200" dirty="0">
                 <a:solidFill>
                   <a:schemeClr val="dk2"/>
                 </a:solidFill>
               </a:rPr>
               <a:t>Con el tiempo, el negocio empezó a depender más de TI (ERP, web, movilidad, cloud).</a:t>
             </a:r>
-            <a:endParaRPr sz="1200">
+            <a:endParaRPr sz="1200" dirty="0">
               <a:solidFill>
                 <a:schemeClr val="dk2"/>
               </a:solidFill>
@@ -11746,14 +11805,14 @@
               <a:buChar char="❖"/>
             </a:pPr>
             <a:r>
-              <a:rPr lang="es" sz="1200" b="1">
+              <a:rPr lang="es" sz="1200" b="1" dirty="0">
                 <a:solidFill>
                   <a:schemeClr val="dk2"/>
                 </a:solidFill>
               </a:rPr>
               <a:t>Hoy, TI es un habilitador del negocio, clave en innovación, eficiencia y competitividad.</a:t>
             </a:r>
-            <a:endParaRPr sz="1200" b="1">
+            <a:endParaRPr sz="1200" b="1" dirty="0">
               <a:solidFill>
                 <a:schemeClr val="dk2"/>
               </a:solidFill>
@@ -11772,7 +11831,7 @@
               </a:spcAft>
               <a:buNone/>
             </a:pPr>
-            <a:endParaRPr sz="1200" b="1">
+            <a:endParaRPr sz="1200" b="1" dirty="0">
               <a:solidFill>
                 <a:schemeClr val="dk2"/>
               </a:solidFill>
@@ -11791,7 +11850,7 @@
               </a:spcAft>
               <a:buNone/>
             </a:pPr>
-            <a:endParaRPr sz="1200">
+            <a:endParaRPr sz="1200" dirty="0">
               <a:solidFill>
                 <a:schemeClr val="dk2"/>
               </a:solidFill>
@@ -11810,7 +11869,7 @@
               </a:spcAft>
               <a:buNone/>
             </a:pPr>
-            <a:endParaRPr sz="1200">
+            <a:endParaRPr sz="1200" dirty="0">
               <a:solidFill>
                 <a:schemeClr val="dk2"/>
               </a:solidFill>
@@ -12002,14 +12061,14 @@
               <a:buNone/>
             </a:pPr>
             <a:r>
-              <a:rPr lang="es" b="1">
+              <a:rPr lang="es" b="1" dirty="0">
                 <a:solidFill>
                   <a:schemeClr val="dk2"/>
                 </a:solidFill>
               </a:rPr>
               <a:t>Evolución GSI - Pasamos a ver a TI como proveedor de Servicios</a:t>
             </a:r>
-            <a:endParaRPr sz="1400" b="1" i="0" u="none" strike="noStrike" cap="none">
+            <a:endParaRPr sz="1400" b="1" i="0" u="none" strike="noStrike" cap="none" dirty="0">
               <a:solidFill>
                 <a:schemeClr val="dk2"/>
               </a:solidFill>
@@ -13294,8 +13353,8 @@
         </p:nvSpPr>
         <p:spPr>
           <a:xfrm>
-            <a:off x="622951" y="810200"/>
-            <a:ext cx="6425400" cy="276900"/>
+            <a:off x="614600" y="810199"/>
+            <a:ext cx="6433751" cy="431535"/>
           </a:xfrm>
           <a:prstGeom prst="rect">
             <a:avLst/>
@@ -13329,14 +13388,14 @@
               <a:buNone/>
             </a:pPr>
             <a:r>
-              <a:rPr lang="es" b="1">
+              <a:rPr lang="es" b="1" dirty="0">
                 <a:solidFill>
                   <a:schemeClr val="dk2"/>
                 </a:solidFill>
               </a:rPr>
               <a:t>GSI - Que son las metodologías</a:t>
             </a:r>
-            <a:endParaRPr sz="1500" b="1" i="0" u="none" strike="noStrike" cap="none">
+            <a:endParaRPr sz="1500" b="1" i="0" u="none" strike="noStrike" cap="none" dirty="0">
               <a:solidFill>
                 <a:schemeClr val="dk2"/>
               </a:solidFill>
@@ -13897,14 +13956,14 @@
               <a:buNone/>
             </a:pPr>
             <a:r>
-              <a:rPr lang="es" b="1">
+              <a:rPr lang="es" b="1" dirty="0">
                 <a:solidFill>
                   <a:schemeClr val="dk2"/>
                 </a:solidFill>
               </a:rPr>
               <a:t>GSI - ¿Que son las normas?</a:t>
             </a:r>
-            <a:endParaRPr sz="1500" b="1" i="0" u="none" strike="noStrike" cap="none">
+            <a:endParaRPr sz="1500" b="1" i="0" u="none" strike="noStrike" cap="none" dirty="0">
               <a:solidFill>
                 <a:schemeClr val="dk2"/>
               </a:solidFill>
@@ -14387,8 +14446,8 @@
         </p:nvSpPr>
         <p:spPr>
           <a:xfrm>
-            <a:off x="622951" y="810200"/>
-            <a:ext cx="6425400" cy="276900"/>
+            <a:off x="622951" y="810199"/>
+            <a:ext cx="6425400" cy="405963"/>
           </a:xfrm>
           <a:prstGeom prst="rect">
             <a:avLst/>
@@ -14422,14 +14481,14 @@
               <a:buNone/>
             </a:pPr>
             <a:r>
-              <a:rPr lang="es" b="1">
+              <a:rPr lang="es" b="1" dirty="0">
                 <a:solidFill>
                   <a:schemeClr val="dk2"/>
                 </a:solidFill>
               </a:rPr>
               <a:t>GSI - ¿Que son las buenas prácticas?</a:t>
             </a:r>
-            <a:endParaRPr sz="1500" b="1" i="0" u="none" strike="noStrike" cap="none">
+            <a:endParaRPr sz="1500" b="1" i="0" u="none" strike="noStrike" cap="none" dirty="0">
               <a:solidFill>
                 <a:schemeClr val="dk2"/>
               </a:solidFill>
@@ -18238,14 +18297,14 @@
               <a:buChar char="❖"/>
             </a:pPr>
             <a:r>
-              <a:rPr lang="es" sz="1200">
+              <a:rPr lang="es" sz="1200" dirty="0">
                 <a:solidFill>
                   <a:schemeClr val="dk2"/>
                 </a:solidFill>
               </a:rPr>
               <a:t>Resultado entregado por un proveedor de TI para facilitar resultados de negocio.</a:t>
             </a:r>
-            <a:endParaRPr sz="1200">
+            <a:endParaRPr sz="1200" dirty="0">
               <a:solidFill>
                 <a:schemeClr val="dk2"/>
               </a:solidFill>
@@ -18269,14 +18328,14 @@
               <a:buChar char="❖"/>
             </a:pPr>
             <a:r>
-              <a:rPr lang="es" sz="1200">
+              <a:rPr lang="es" sz="1200" dirty="0">
                 <a:solidFill>
                   <a:schemeClr val="dk2"/>
                 </a:solidFill>
               </a:rPr>
               <a:t>No se limita al software o hardware: incluye soporte, mantenimiento, disponibilidad.</a:t>
             </a:r>
-            <a:endParaRPr sz="1200">
+            <a:endParaRPr sz="1200" dirty="0">
               <a:solidFill>
                 <a:schemeClr val="dk2"/>
               </a:solidFill>
@@ -18300,14 +18359,14 @@
               <a:buChar char="❖"/>
             </a:pPr>
             <a:r>
-              <a:rPr lang="es" sz="1200">
+              <a:rPr lang="es" sz="1200" dirty="0">
                 <a:solidFill>
                   <a:schemeClr val="dk2"/>
                 </a:solidFill>
               </a:rPr>
               <a:t>Se enfoca en el valor para el usuario, no solo en la tecnología.</a:t>
             </a:r>
-            <a:endParaRPr sz="1200">
+            <a:endParaRPr sz="1200" dirty="0">
               <a:solidFill>
                 <a:schemeClr val="dk2"/>
               </a:solidFill>
@@ -18331,14 +18390,14 @@
               <a:buChar char="❖"/>
             </a:pPr>
             <a:r>
-              <a:rPr lang="es" sz="1200">
+              <a:rPr lang="es" sz="1200" dirty="0">
                 <a:solidFill>
                   <a:schemeClr val="dk2"/>
                 </a:solidFill>
               </a:rPr>
               <a:t>Ejemplos de servicios de TI:</a:t>
             </a:r>
-            <a:endParaRPr sz="1200">
+            <a:endParaRPr sz="1200" dirty="0">
               <a:solidFill>
                 <a:schemeClr val="dk2"/>
               </a:solidFill>
@@ -18362,14 +18421,14 @@
               <a:buChar char="➢"/>
             </a:pPr>
             <a:r>
-              <a:rPr lang="es" sz="1200">
+              <a:rPr lang="es" sz="1200" dirty="0">
                 <a:solidFill>
                   <a:schemeClr val="dk2"/>
                 </a:solidFill>
               </a:rPr>
               <a:t>Correo corporativo (ej. Outlook Exchange)</a:t>
             </a:r>
-            <a:endParaRPr sz="1200">
+            <a:endParaRPr sz="1200" dirty="0">
               <a:solidFill>
                 <a:schemeClr val="dk2"/>
               </a:solidFill>
@@ -18393,14 +18452,14 @@
               <a:buChar char="➢"/>
             </a:pPr>
             <a:r>
-              <a:rPr lang="es" sz="1200">
+              <a:rPr lang="es" sz="1200" dirty="0">
                 <a:solidFill>
                   <a:schemeClr val="dk2"/>
                 </a:solidFill>
               </a:rPr>
               <a:t>Acceso a red e Internet</a:t>
             </a:r>
-            <a:endParaRPr sz="1200">
+            <a:endParaRPr sz="1200" dirty="0">
               <a:solidFill>
                 <a:schemeClr val="dk2"/>
               </a:solidFill>
@@ -18424,14 +18483,14 @@
               <a:buChar char="➢"/>
             </a:pPr>
             <a:r>
-              <a:rPr lang="es" sz="1200">
+              <a:rPr lang="es" sz="1200" dirty="0">
                 <a:solidFill>
                   <a:schemeClr val="dk2"/>
                 </a:solidFill>
               </a:rPr>
               <a:t>ERP (SAP, Oracle)</a:t>
             </a:r>
-            <a:endParaRPr sz="1200">
+            <a:endParaRPr sz="1200" dirty="0">
               <a:solidFill>
                 <a:schemeClr val="dk2"/>
               </a:solidFill>
@@ -18455,14 +18514,14 @@
               <a:buChar char="➢"/>
             </a:pPr>
             <a:r>
-              <a:rPr lang="es" sz="1200">
+              <a:rPr lang="es" sz="1200" dirty="0">
                 <a:solidFill>
                   <a:schemeClr val="dk2"/>
                 </a:solidFill>
               </a:rPr>
               <a:t>Service Desk / Soporte técnico</a:t>
             </a:r>
-            <a:endParaRPr sz="1200">
+            <a:endParaRPr sz="1200" dirty="0">
               <a:solidFill>
                 <a:schemeClr val="dk2"/>
               </a:solidFill>
@@ -18486,14 +18545,14 @@
               <a:buChar char="➢"/>
             </a:pPr>
             <a:r>
-              <a:rPr lang="es" sz="1200">
+              <a:rPr lang="es" sz="1200" dirty="0">
                 <a:solidFill>
                   <a:schemeClr val="dk2"/>
                 </a:solidFill>
               </a:rPr>
               <a:t>Gestión de identidades (crear usuarios, accesos)</a:t>
             </a:r>
-            <a:endParaRPr sz="1200">
+            <a:endParaRPr sz="1200" dirty="0">
               <a:solidFill>
                 <a:schemeClr val="dk2"/>
               </a:solidFill>
@@ -19130,14 +19189,14 @@
               <a:buChar char="❖"/>
             </a:pPr>
             <a:r>
-              <a:rPr lang="es" sz="1200">
+              <a:rPr lang="es" sz="1200" dirty="0">
                 <a:solidFill>
                   <a:schemeClr val="dk2"/>
                 </a:solidFill>
               </a:rPr>
               <a:t>Los procesos de negocio dependen de servicios de TI eficientes.</a:t>
             </a:r>
-            <a:endParaRPr sz="1200">
+            <a:endParaRPr sz="1200" dirty="0">
               <a:solidFill>
                 <a:schemeClr val="dk2"/>
               </a:solidFill>
@@ -19161,14 +19220,14 @@
               <a:buChar char="❖"/>
             </a:pPr>
             <a:r>
-              <a:rPr lang="es" sz="1200">
+              <a:rPr lang="es" sz="1200" dirty="0">
                 <a:solidFill>
                   <a:schemeClr val="dk2"/>
                 </a:solidFill>
               </a:rPr>
               <a:t>Ejemplos:</a:t>
             </a:r>
-            <a:endParaRPr sz="1200">
+            <a:endParaRPr sz="1200" dirty="0">
               <a:solidFill>
                 <a:schemeClr val="dk2"/>
               </a:solidFill>
@@ -19192,14 +19251,14 @@
               <a:buChar char="➢"/>
             </a:pPr>
             <a:r>
-              <a:rPr lang="es" sz="1200">
+              <a:rPr lang="es" sz="1200" dirty="0">
                 <a:solidFill>
                   <a:schemeClr val="dk2"/>
                 </a:solidFill>
               </a:rPr>
               <a:t>Proceso de ventas → requiere CRM, red, dispositivos.</a:t>
             </a:r>
-            <a:endParaRPr sz="1200">
+            <a:endParaRPr sz="1200" dirty="0">
               <a:solidFill>
                 <a:schemeClr val="dk2"/>
               </a:solidFill>
@@ -19223,14 +19282,14 @@
               <a:buChar char="➢"/>
             </a:pPr>
             <a:r>
-              <a:rPr lang="es" sz="1200">
+              <a:rPr lang="es" sz="1200" dirty="0">
                 <a:solidFill>
                   <a:schemeClr val="dk2"/>
                 </a:solidFill>
               </a:rPr>
               <a:t>Logística → necesita ERP y conectividad con proveedores.</a:t>
             </a:r>
-            <a:endParaRPr sz="1200">
+            <a:endParaRPr sz="1200" dirty="0">
               <a:solidFill>
                 <a:schemeClr val="dk2"/>
               </a:solidFill>
@@ -19254,14 +19313,14 @@
               <a:buChar char="➢"/>
             </a:pPr>
             <a:r>
-              <a:rPr lang="es" sz="1200">
+              <a:rPr lang="es" sz="1200" dirty="0">
                 <a:solidFill>
                   <a:schemeClr val="dk2"/>
                 </a:solidFill>
               </a:rPr>
               <a:t>Recursos Humanos → usa sistemas de nómina, gestión de talento.</a:t>
             </a:r>
-            <a:endParaRPr sz="1200">
+            <a:endParaRPr sz="1200" dirty="0">
               <a:solidFill>
                 <a:schemeClr val="dk2"/>
               </a:solidFill>
@@ -19280,7 +19339,7 @@
               </a:spcAft>
               <a:buNone/>
             </a:pPr>
-            <a:endParaRPr sz="1200">
+            <a:endParaRPr sz="1200" dirty="0">
               <a:solidFill>
                 <a:schemeClr val="dk2"/>
               </a:solidFill>
@@ -19304,14 +19363,14 @@
               <a:buChar char="❖"/>
             </a:pPr>
             <a:r>
-              <a:rPr lang="es" sz="1200">
+              <a:rPr lang="es" sz="1200" dirty="0">
                 <a:solidFill>
                   <a:schemeClr val="dk2"/>
                 </a:solidFill>
               </a:rPr>
               <a:t>Si el servicio de TI falla, el proceso de negocio se ve afectado.</a:t>
             </a:r>
-            <a:endParaRPr sz="1200">
+            <a:endParaRPr sz="1200" dirty="0">
               <a:solidFill>
                 <a:schemeClr val="dk2"/>
               </a:solidFill>
@@ -19335,14 +19394,14 @@
               <a:buChar char="❖"/>
             </a:pPr>
             <a:r>
-              <a:rPr lang="es" sz="1200">
+              <a:rPr lang="es" sz="1200" dirty="0">
                 <a:solidFill>
                   <a:schemeClr val="dk2"/>
                 </a:solidFill>
               </a:rPr>
               <a:t>La gestión de servicios busca alinear TI con las necesidades del negocio</a:t>
             </a:r>
-            <a:endParaRPr sz="1200">
+            <a:endParaRPr sz="1200" dirty="0">
               <a:solidFill>
                 <a:schemeClr val="dk2"/>
               </a:solidFill>
@@ -19595,14 +19654,14 @@
               <a:buChar char="❖"/>
             </a:pPr>
             <a:r>
-              <a:rPr lang="es" sz="1200">
+              <a:rPr lang="es" sz="1200" dirty="0">
                 <a:solidFill>
                   <a:schemeClr val="dk2"/>
                 </a:solidFill>
               </a:rPr>
               <a:t>Servicio de turnos en un hospital.</a:t>
             </a:r>
-            <a:endParaRPr sz="1200">
+            <a:endParaRPr sz="1200" dirty="0">
               <a:solidFill>
                 <a:schemeClr val="dk2"/>
               </a:solidFill>
@@ -19626,14 +19685,14 @@
               <a:buChar char="➢"/>
             </a:pPr>
             <a:r>
-              <a:rPr lang="es" sz="1200">
+              <a:rPr lang="es" sz="1200" dirty="0">
                 <a:solidFill>
                   <a:schemeClr val="dk2"/>
                 </a:solidFill>
               </a:rPr>
               <a:t>Gestión de citas médicas, disponibilidad de profesionales, atención al paciente y retroalimentación.</a:t>
             </a:r>
-            <a:endParaRPr sz="1200">
+            <a:endParaRPr sz="1200" dirty="0">
               <a:solidFill>
                 <a:schemeClr val="dk2"/>
               </a:solidFill>
@@ -19657,14 +19716,14 @@
               <a:buChar char="➢"/>
             </a:pPr>
             <a:r>
-              <a:rPr lang="es" sz="1200">
+              <a:rPr lang="es" sz="1200" dirty="0">
                 <a:solidFill>
                   <a:schemeClr val="dk2"/>
                 </a:solidFill>
               </a:rPr>
               <a:t>Aplicar GSI implica definir tiempos de atención, experiencia del usuario, gestión de quejas, etc.</a:t>
             </a:r>
-            <a:endParaRPr sz="1200">
+            <a:endParaRPr sz="1200" dirty="0">
               <a:solidFill>
                 <a:schemeClr val="dk2"/>
               </a:solidFill>
@@ -19688,14 +19747,14 @@
               <a:buChar char="❖"/>
             </a:pPr>
             <a:r>
-              <a:rPr lang="es" sz="1200">
+              <a:rPr lang="es" sz="1200" dirty="0">
                 <a:solidFill>
                   <a:schemeClr val="dk2"/>
                 </a:solidFill>
               </a:rPr>
               <a:t>Entrega de productos en e-commerce.</a:t>
             </a:r>
-            <a:endParaRPr sz="1200">
+            <a:endParaRPr sz="1200" dirty="0">
               <a:solidFill>
                 <a:schemeClr val="dk2"/>
               </a:solidFill>
@@ -19719,14 +19778,14 @@
               <a:buChar char="➢"/>
             </a:pPr>
             <a:r>
-              <a:rPr lang="es" sz="1200">
+              <a:rPr lang="es" sz="1200" dirty="0">
                 <a:solidFill>
                   <a:schemeClr val="dk2"/>
                 </a:solidFill>
               </a:rPr>
               <a:t>Desde que el cliente compra hasta que recibe el producto: seguimiento, atención postventa, devoluciones.</a:t>
             </a:r>
-            <a:endParaRPr sz="1200">
+            <a:endParaRPr sz="1200" dirty="0">
               <a:solidFill>
                 <a:schemeClr val="dk2"/>
               </a:solidFill>
@@ -19750,14 +19809,14 @@
               <a:buChar char="➢"/>
             </a:pPr>
             <a:r>
-              <a:rPr lang="es" sz="1200">
+              <a:rPr lang="es" sz="1200" dirty="0">
                 <a:solidFill>
                   <a:schemeClr val="dk2"/>
                 </a:solidFill>
               </a:rPr>
               <a:t>GSI aquí sería establecer métricas de entrega (tiempo, calidad), puntos de contacto y mejora continua.</a:t>
             </a:r>
-            <a:endParaRPr sz="1200">
+            <a:endParaRPr sz="1200" dirty="0">
               <a:solidFill>
                 <a:schemeClr val="dk2"/>
               </a:solidFill>
@@ -20010,14 +20069,14 @@
               <a:buChar char="❖"/>
             </a:pPr>
             <a:r>
-              <a:rPr lang="es" sz="1200">
+              <a:rPr lang="es" sz="1200" dirty="0">
                 <a:solidFill>
                   <a:schemeClr val="dk2"/>
                 </a:solidFill>
               </a:rPr>
               <a:t>Utilidad (“fit for purpose”):</a:t>
             </a:r>
-            <a:endParaRPr sz="1200">
+            <a:endParaRPr sz="1200" dirty="0">
               <a:solidFill>
                 <a:schemeClr val="dk2"/>
               </a:solidFill>
@@ -20041,14 +20100,14 @@
               <a:buChar char="➢"/>
             </a:pPr>
             <a:r>
-              <a:rPr lang="es" sz="1200">
+              <a:rPr lang="es" sz="1200" dirty="0">
                 <a:solidFill>
                   <a:schemeClr val="dk2"/>
                 </a:solidFill>
               </a:rPr>
               <a:t>¿El servicio cumple con lo que necesito?</a:t>
             </a:r>
-            <a:endParaRPr sz="1200">
+            <a:endParaRPr sz="1200" dirty="0">
               <a:solidFill>
                 <a:schemeClr val="dk2"/>
               </a:solidFill>
@@ -20072,14 +20131,14 @@
               <a:buChar char="➢"/>
             </a:pPr>
             <a:r>
-              <a:rPr lang="es" sz="1200">
+              <a:rPr lang="es" sz="1200" dirty="0">
                 <a:solidFill>
                   <a:schemeClr val="dk2"/>
                 </a:solidFill>
               </a:rPr>
               <a:t>Ejemplo: ¿El correo permite enviar y recibir con normalidad?</a:t>
             </a:r>
-            <a:endParaRPr sz="1200">
+            <a:endParaRPr sz="1200" dirty="0">
               <a:solidFill>
                 <a:schemeClr val="dk2"/>
               </a:solidFill>
@@ -20103,14 +20162,14 @@
               <a:buChar char="❖"/>
             </a:pPr>
             <a:r>
-              <a:rPr lang="es" sz="1200">
+              <a:rPr lang="es" sz="1200" dirty="0">
                 <a:solidFill>
                   <a:schemeClr val="dk2"/>
                 </a:solidFill>
               </a:rPr>
               <a:t>Garantía (“fit for use”):</a:t>
             </a:r>
-            <a:endParaRPr sz="1200">
+            <a:endParaRPr sz="1200" dirty="0">
               <a:solidFill>
                 <a:schemeClr val="dk2"/>
               </a:solidFill>
@@ -20134,14 +20193,14 @@
               <a:buChar char="➢"/>
             </a:pPr>
             <a:r>
-              <a:rPr lang="es" sz="1200">
+              <a:rPr lang="es" sz="1200" dirty="0">
                 <a:solidFill>
                   <a:schemeClr val="dk2"/>
                 </a:solidFill>
               </a:rPr>
               <a:t>¿El servicio está disponible, es confiable, seguro?</a:t>
             </a:r>
-            <a:endParaRPr sz="1200">
+            <a:endParaRPr sz="1200" dirty="0">
               <a:solidFill>
                 <a:schemeClr val="dk2"/>
               </a:solidFill>
@@ -20165,14 +20224,14 @@
               <a:buChar char="➢"/>
             </a:pPr>
             <a:r>
-              <a:rPr lang="es" sz="1200">
+              <a:rPr lang="es" sz="1200" dirty="0">
                 <a:solidFill>
                   <a:schemeClr val="dk2"/>
                 </a:solidFill>
               </a:rPr>
               <a:t>Ejemplo: ¿Está disponible 99.9% del tiempo? ¿Es rápido y seguro?</a:t>
             </a:r>
-            <a:endParaRPr sz="1200">
+            <a:endParaRPr sz="1200" dirty="0">
               <a:solidFill>
                 <a:schemeClr val="dk2"/>
               </a:solidFill>
@@ -20196,14 +20255,14 @@
               <a:buChar char="❖"/>
             </a:pPr>
             <a:r>
-              <a:rPr lang="es" sz="1200">
+              <a:rPr lang="es" sz="1200" dirty="0">
                 <a:solidFill>
                   <a:schemeClr val="dk2"/>
                 </a:solidFill>
               </a:rPr>
               <a:t>Ambos aspectos son necesarios para que un servicio sea valioso</a:t>
             </a:r>
-            <a:endParaRPr sz="1200">
+            <a:endParaRPr sz="1200" dirty="0">
               <a:solidFill>
                 <a:schemeClr val="dk2"/>
               </a:solidFill>
@@ -20451,7 +20510,7 @@
               </a:spcAft>
               <a:buNone/>
             </a:pPr>
-            <a:endParaRPr sz="1200">
+            <a:endParaRPr sz="1200" dirty="0">
               <a:solidFill>
                 <a:schemeClr val="dk2"/>
               </a:solidFill>
@@ -20475,14 +20534,14 @@
               <a:buChar char="❖"/>
             </a:pPr>
             <a:r>
-              <a:rPr lang="es" sz="1200">
+              <a:rPr lang="es" sz="1200" dirty="0">
                 <a:solidFill>
                   <a:schemeClr val="dk2"/>
                 </a:solidFill>
               </a:rPr>
               <a:t>TI creció rápidamente, pero sin un enfoque estructurado.</a:t>
             </a:r>
-            <a:endParaRPr sz="1200">
+            <a:endParaRPr sz="1200" dirty="0">
               <a:solidFill>
                 <a:schemeClr val="dk2"/>
               </a:solidFill>
@@ -20506,14 +20565,14 @@
               <a:buChar char="❖"/>
             </a:pPr>
             <a:r>
-              <a:rPr lang="es" sz="1200">
+              <a:rPr lang="es" sz="1200" dirty="0">
                 <a:solidFill>
                   <a:schemeClr val="dk2"/>
                 </a:solidFill>
               </a:rPr>
               <a:t>Las áreas técnicas se centraban en infraestructura, no en el usuario.</a:t>
             </a:r>
-            <a:endParaRPr sz="1200">
+            <a:endParaRPr sz="1200" dirty="0">
               <a:solidFill>
                 <a:schemeClr val="dk2"/>
               </a:solidFill>
@@ -20537,14 +20596,14 @@
               <a:buChar char="❖"/>
             </a:pPr>
             <a:r>
-              <a:rPr lang="es" sz="1200">
+              <a:rPr lang="es" sz="1200" dirty="0">
                 <a:solidFill>
                   <a:schemeClr val="dk2"/>
                 </a:solidFill>
               </a:rPr>
               <a:t>El negocio necesitaba servicios confiables, medibles y alineados a sus objetivos.</a:t>
             </a:r>
-            <a:endParaRPr sz="1200">
+            <a:endParaRPr sz="1200" dirty="0">
               <a:solidFill>
                 <a:schemeClr val="dk2"/>
               </a:solidFill>
@@ -20568,14 +20627,14 @@
               <a:buChar char="❖"/>
             </a:pPr>
             <a:r>
-              <a:rPr lang="es" sz="1200">
+              <a:rPr lang="es" sz="1200" dirty="0">
                 <a:solidFill>
                   <a:schemeClr val="dk2"/>
                 </a:solidFill>
               </a:rPr>
               <a:t>Emergió la necesidad de gestionar TI como un servicio, no como un conjunto de recursos.</a:t>
             </a:r>
-            <a:endParaRPr sz="1200">
+            <a:endParaRPr sz="1200" dirty="0">
               <a:solidFill>
                 <a:schemeClr val="dk2"/>
               </a:solidFill>

</xml_diff>